<commit_message>
Test 12.2 Revvo : logo pptx
</commit_message>
<xml_diff>
--- a/12.2/demo-poste-revvo-deck.pptx
+++ b/12.2/demo-poste-revvo-deck.pptx
@@ -4492,7 +4492,7 @@
         </p:blipFill>
         <p:spPr>
           <a:xfrm>
-            <a:off x="10980000" y="324000"/>
+            <a:off x="10512000" y="324000"/>
             <a:ext cx="1329702" cy="504000"/>
           </a:xfrm>
           <a:prstGeom prst="rect">
@@ -4509,7 +4509,7 @@
         <p:spPr>
           <a:xfrm>
             <a:off x="864000" y="432000"/>
-            <a:ext cx="9540000" cy="1080000"/>
+            <a:ext cx="9432000" cy="1080000"/>
           </a:xfrm>
           <a:prstGeom prst="rect">
             <a:avLst/>
@@ -4847,7 +4847,7 @@
         </p:blipFill>
         <p:spPr>
           <a:xfrm>
-            <a:off x="10980000" y="324000"/>
+            <a:off x="10512000" y="324000"/>
             <a:ext cx="1329702" cy="504000"/>
           </a:xfrm>
           <a:prstGeom prst="rect">
@@ -4864,7 +4864,7 @@
         <p:spPr>
           <a:xfrm>
             <a:off x="864000" y="432000"/>
-            <a:ext cx="9540000" cy="1080000"/>
+            <a:ext cx="9432000" cy="1080000"/>
           </a:xfrm>
           <a:prstGeom prst="rect">
             <a:avLst/>
@@ -5157,7 +5157,7 @@
         </p:blipFill>
         <p:spPr>
           <a:xfrm>
-            <a:off x="10980000" y="324000"/>
+            <a:off x="10512000" y="324000"/>
             <a:ext cx="1329702" cy="504000"/>
           </a:xfrm>
           <a:prstGeom prst="rect">
@@ -5174,7 +5174,7 @@
         <p:spPr>
           <a:xfrm>
             <a:off x="864000" y="432000"/>
-            <a:ext cx="9540000" cy="1080000"/>
+            <a:ext cx="9432000" cy="1080000"/>
           </a:xfrm>
           <a:prstGeom prst="rect">
             <a:avLst/>
@@ -5522,7 +5522,7 @@
         </p:blipFill>
         <p:spPr>
           <a:xfrm>
-            <a:off x="10980000" y="324000"/>
+            <a:off x="10512000" y="324000"/>
             <a:ext cx="1329702" cy="504000"/>
           </a:xfrm>
           <a:prstGeom prst="rect">
@@ -5539,7 +5539,7 @@
         <p:spPr>
           <a:xfrm>
             <a:off x="864000" y="432000"/>
-            <a:ext cx="9540000" cy="1080000"/>
+            <a:ext cx="9432000" cy="1080000"/>
           </a:xfrm>
           <a:prstGeom prst="rect">
             <a:avLst/>
@@ -6018,7 +6018,7 @@
         </p:blipFill>
         <p:spPr>
           <a:xfrm>
-            <a:off x="10980000" y="324000"/>
+            <a:off x="10512000" y="324000"/>
             <a:ext cx="1329702" cy="504000"/>
           </a:xfrm>
           <a:prstGeom prst="rect">
@@ -6035,7 +6035,7 @@
         <p:spPr>
           <a:xfrm>
             <a:off x="864000" y="432000"/>
-            <a:ext cx="9540000" cy="1080000"/>
+            <a:ext cx="9432000" cy="1080000"/>
           </a:xfrm>
           <a:prstGeom prst="rect">
             <a:avLst/>
@@ -6613,7 +6613,7 @@
         </p:blipFill>
         <p:spPr>
           <a:xfrm>
-            <a:off x="10980000" y="324000"/>
+            <a:off x="10512000" y="324000"/>
             <a:ext cx="1329702" cy="504000"/>
           </a:xfrm>
           <a:prstGeom prst="rect">
@@ -6630,7 +6630,7 @@
         <p:spPr>
           <a:xfrm>
             <a:off x="864000" y="432000"/>
-            <a:ext cx="9540000" cy="1080000"/>
+            <a:ext cx="9432000" cy="1080000"/>
           </a:xfrm>
           <a:prstGeom prst="rect">
             <a:avLst/>
@@ -7489,7 +7489,7 @@
         </p:blipFill>
         <p:spPr>
           <a:xfrm>
-            <a:off x="10980000" y="324000"/>
+            <a:off x="10512000" y="324000"/>
             <a:ext cx="1329702" cy="504000"/>
           </a:xfrm>
           <a:prstGeom prst="rect">
@@ -7506,7 +7506,7 @@
         <p:spPr>
           <a:xfrm>
             <a:off x="864000" y="432000"/>
-            <a:ext cx="9540000" cy="1080000"/>
+            <a:ext cx="9432000" cy="1080000"/>
           </a:xfrm>
           <a:prstGeom prst="rect">
             <a:avLst/>
@@ -7985,7 +7985,7 @@
         </p:blipFill>
         <p:spPr>
           <a:xfrm>
-            <a:off x="10980000" y="324000"/>
+            <a:off x="10512000" y="324000"/>
             <a:ext cx="1329702" cy="504000"/>
           </a:xfrm>
           <a:prstGeom prst="rect">
@@ -8002,7 +8002,7 @@
         <p:spPr>
           <a:xfrm>
             <a:off x="864000" y="432000"/>
-            <a:ext cx="9540000" cy="1080000"/>
+            <a:ext cx="9432000" cy="1080000"/>
           </a:xfrm>
           <a:prstGeom prst="rect">
             <a:avLst/>
@@ -8698,7 +8698,7 @@
         </p:blipFill>
         <p:spPr>
           <a:xfrm>
-            <a:off x="10980000" y="324000"/>
+            <a:off x="10512000" y="324000"/>
             <a:ext cx="1329702" cy="504000"/>
           </a:xfrm>
           <a:prstGeom prst="rect">
@@ -8715,7 +8715,7 @@
         <p:spPr>
           <a:xfrm>
             <a:off x="864000" y="432000"/>
-            <a:ext cx="9540000" cy="1080000"/>
+            <a:ext cx="9432000" cy="1080000"/>
           </a:xfrm>
           <a:prstGeom prst="rect">
             <a:avLst/>
@@ -9116,7 +9116,7 @@
         </p:blipFill>
         <p:spPr>
           <a:xfrm>
-            <a:off x="10980000" y="324000"/>
+            <a:off x="10512000" y="324000"/>
             <a:ext cx="1329702" cy="504000"/>
           </a:xfrm>
           <a:prstGeom prst="rect">
@@ -9133,7 +9133,7 @@
         <p:spPr>
           <a:xfrm>
             <a:off x="864000" y="432000"/>
-            <a:ext cx="9540000" cy="1080000"/>
+            <a:ext cx="9432000" cy="1080000"/>
           </a:xfrm>
           <a:prstGeom prst="rect">
             <a:avLst/>

</xml_diff>